<commit_message>
Bake the live prototype URL into the deck
App deployed at https://glassbox-unihack.streamlit.app/ on Python 3.12, verified
rendering with real metrics (250 rows, 97.2% classified, 100% invoice and
vocabulary compliance).

The Links slide now carries the real URL, and the video row states that the link
is submitted alongside the deck rather than showing an unfilled placeholder.

build_deck.py takes --prototype-url / --video-url / --members so the deck can be
regenerated against final links in one command.
</commit_message>
<xml_diff>
--- a/outputs/GlassBox_UniHack_Deck.pptx
+++ b/outputs/GlassBox_UniHack_Deck.pptx
@@ -16165,7 +16165,7 @@
             </a:avLst>
           </a:prstGeom>
           <a:solidFill>
-            <a:srgbClr val="FDF6E7"/>
+            <a:srgbClr val="FFFFFF"/>
           </a:solidFill>
           <a:ln w="9525">
             <a:solidFill>
@@ -16206,7 +16206,7 @@
             <a:r>
               <a:rPr sz="850" b="1" i="0">
                 <a:solidFill>
-                  <a:srgbClr val="B47A0A"/>
+                  <a:srgbClr val="0E8F69"/>
                 </a:solidFill>
                 <a:latin typeface="Calibri"/>
               </a:rPr>
@@ -16226,13 +16226,13 @@
               </a:spcAft>
             </a:pPr>
             <a:r>
-              <a:rPr sz="1200" b="0" i="0">
-                <a:solidFill>
-                  <a:srgbClr val="B47A0A"/>
+              <a:rPr sz="1200" b="1" i="0">
+                <a:solidFill>
+                  <a:srgbClr val="1A1F25"/>
                 </a:solidFill>
                 <a:latin typeface="Calibri"/>
               </a:rPr>
-              <a:t>&lt;paste your Streamlit / Hugging Face Space URL&gt;</a:t>
+              <a:t>https://glassbox-unihack.streamlit.app/</a:t>
             </a:r>
           </a:p>
         </p:txBody>
@@ -16315,13 +16315,13 @@
               </a:spcAft>
             </a:pPr>
             <a:r>
-              <a:rPr sz="1200" b="0" i="0">
+              <a:rPr sz="1100" b="0" i="0">
                 <a:solidFill>
                   <a:srgbClr val="B47A0A"/>
                 </a:solidFill>
                 <a:latin typeface="Calibri"/>
               </a:rPr>
-              <a:t>&lt;paste your unlisted YouTube URL&gt;</a:t>
+              <a:t>Submitted alongside this deck on the Hack2skill portal</a:t>
             </a:r>
           </a:p>
         </p:txBody>
@@ -17493,7 +17493,7 @@
                 </a:solidFill>
                 <a:latin typeface="Calibri"/>
               </a:rPr>
-              <a:t>204</a:t>
+              <a:t>214</a:t>
             </a:r>
           </a:p>
           <a:p>
@@ -18898,7 +18898,7 @@
                 </a:solidFill>
                 <a:latin typeface="Calibri"/>
               </a:rPr>
-              <a:t>204/s</a:t>
+              <a:t>214/s</a:t>
             </a:r>
           </a:p>
           <a:p>

</xml_diff>